<commit_message>
Update presentation slides to translate ML jargon into business-ready actionable insights
</commit_message>
<xml_diff>
--- a/PRESENTATION.pptx
+++ b/PRESENTATION.pptx
@@ -7343,7 +7343,7 @@
                 </a:solidFill>
                 <a:latin typeface="Calibri"/>
               </a:rPr>
-              <a:t>Bundle rules + a 21-SKU Pareto shortlist</a:t>
+              <a:t>Predictive stocking shortlist + direct bundling rules</a:t>
             </a:r>
           </a:p>
         </p:txBody>
@@ -7470,7 +7470,7 @@
                 </a:solidFill>
                 <a:latin typeface="Calibri"/>
               </a:rPr>
-              <a:t>Rules found</a:t>
+              <a:t>Bundle Rules Found</a:t>
             </a:r>
           </a:p>
         </p:txBody>
@@ -7584,7 +7584,7 @@
                 </a:solidFill>
                 <a:latin typeface="Calibri"/>
               </a:rPr>
-              <a:t>Top lift</a:t>
+              <a:t>Rule Strength (Lift)</a:t>
             </a:r>
           </a:p>
         </p:txBody>
@@ -7619,7 +7619,7 @@
                 </a:solidFill>
                 <a:latin typeface="Calibri"/>
               </a:rPr>
-              <a:t>18.59</a:t>
+              <a:t>18.6x</a:t>
             </a:r>
           </a:p>
         </p:txBody>
@@ -7698,7 +7698,7 @@
                 </a:solidFill>
                 <a:latin typeface="Calibri"/>
               </a:rPr>
-              <a:t>Top confidence</a:t>
+              <a:t>Bundling Confidence</a:t>
             </a:r>
           </a:p>
         </p:txBody>
@@ -7812,7 +7812,7 @@
                 </a:solidFill>
                 <a:latin typeface="Calibri"/>
               </a:rPr>
-              <a:t>Pareto 80% / 90%</a:t>
+              <a:t>80% / 90% SKU Headcount</a:t>
             </a:r>
           </a:p>
         </p:txBody>
@@ -7847,7 +7847,7 @@
                 </a:solidFill>
                 <a:latin typeface="Calibri"/>
               </a:rPr>
-              <a:t>20 / 26</a:t>
+              <a:t>20 / 26 SKUs</a:t>
             </a:r>
           </a:p>
         </p:txBody>
@@ -7933,7 +7933,7 @@
                 </a:solidFill>
                 <a:latin typeface="Calibri"/>
               </a:rPr>
-              <a:t>Lock the Pareto-head SKUs at every regional warehouse</a:t>
+              <a:t>Stock the top 20 high-demand add-on parts at every regional warehouse to satisfy 80% of extra demand.</a:t>
             </a:r>
           </a:p>
           <a:p>
@@ -7961,7 +7961,7 @@
                 </a:solidFill>
                 <a:latin typeface="Calibri"/>
               </a:rPr>
-              <a:t>Pilot one bundle rule per pump series next to the standard PM kit</a:t>
+              <a:t>Bundle complementary wear-and-tear parts (e.g. O-rings + Seals) directly into standard PM kits.</a:t>
             </a:r>
           </a:p>
           <a:p>
@@ -7989,7 +7989,7 @@
                 </a:solidFill>
                 <a:latin typeface="Calibri"/>
               </a:rPr>
-              <a:t>Track the 'first-visit completion' rate before vs after roll-out</a:t>
+              <a:t>Verify first-visit completion rates before vs. after roll-out to measure customer satisfaction gains.</a:t>
             </a:r>
           </a:p>
         </p:txBody>
@@ -8268,7 +8268,7 @@
                 </a:solidFill>
                 <a:latin typeface="Calibri"/>
               </a:rPr>
-              <a:t>WORK PACKAGE 2 · REPAIR-DURATION PREDICTION</a:t>
+              <a:t>WORK PACKAGE 2 · REPAIR DURATION</a:t>
             </a:r>
           </a:p>
         </p:txBody>
@@ -8373,7 +8373,7 @@
                 </a:solidFill>
                 <a:latin typeface="Calibri"/>
               </a:rPr>
-              <a:t>The service planner must commit to a customer-facing window. The model must use only intake-safe features (no QA or post-repair fields) and remain explainable to a front-desk advisor.</a:t>
+              <a:t>The service planner must commit to a reliable repair completion date. The prediction model must use only safe, intake-time features (no QA or completion fields) and stay fully explainable to a front-desk advisor.</a:t>
             </a:r>
           </a:p>
         </p:txBody>
@@ -8459,7 +8459,7 @@
                 </a:solidFill>
                 <a:latin typeface="Calibri"/>
               </a:rPr>
-              <a:t>Target: repair_duration_days (right-skewed)</a:t>
+              <a:t>Target: Actual Repair Duration (in Days)</a:t>
             </a:r>
           </a:p>
           <a:p>
@@ -8487,7 +8487,7 @@
                 </a:solidFill>
                 <a:latin typeface="Calibri"/>
               </a:rPr>
-              <a:t>Numeric: pump_age_years, technician_experience_years, parts_cost_eur</a:t>
+              <a:t>Predictors: Pump age, technician experience, estimated parts cost</a:t>
             </a:r>
           </a:p>
           <a:p>
@@ -8515,7 +8515,7 @@
                 </a:solidFill>
                 <a:latin typeface="Calibri"/>
               </a:rPr>
-              <a:t>Categorical: pump_model, complexity_class, failure_type, parts_from_hq_flag, region</a:t>
+              <a:t>Job Info: Specific pump model, failure category, complexity level, region</a:t>
             </a:r>
           </a:p>
           <a:p>
@@ -8543,7 +8543,7 @@
                 </a:solidFill>
                 <a:latin typeface="Calibri"/>
               </a:rPr>
-              <a:t>Preparation: dropna + one-hot encoding (no scaler)</a:t>
+              <a:t>Preparation: Clean incomplete records + format categorical groups</a:t>
             </a:r>
           </a:p>
         </p:txBody>
@@ -8666,7 +8666,7 @@
                 </a:solidFill>
                 <a:latin typeface="Calibri"/>
               </a:rPr>
-              <a:t>Decision Tree Regressor (CART)</a:t>
+              <a:t>Decision Tree Regressor (Whitebox AI)</a:t>
             </a:r>
           </a:p>
         </p:txBody>
@@ -8717,7 +8717,7 @@
                 </a:solidFill>
                 <a:latin typeface="Calibri"/>
               </a:rPr>
-              <a:t>One interpretable algorithm — splits readable on a whiteboard</a:t>
+              <a:t>Fully transparent method — logic splits readable on a whiteboard</a:t>
             </a:r>
           </a:p>
           <a:p>
@@ -8745,7 +8745,7 @@
                 </a:solidFill>
                 <a:latin typeface="Calibri"/>
               </a:rPr>
-              <a:t>Trees are scale-free and need no target transform</a:t>
+              <a:t>Decision paths trace exactly how job drivers add up to the ETA</a:t>
             </a:r>
           </a:p>
           <a:p>
@@ -8773,7 +8773,7 @@
                 </a:solidFill>
                 <a:latin typeface="Calibri"/>
               </a:rPr>
-              <a:t>80/20 train/test split, seed = 7, evaluated on held-out data</a:t>
+              <a:t>Evaluated on a completely separate, held-out test dataset</a:t>
             </a:r>
           </a:p>
         </p:txBody>
@@ -8859,7 +8859,7 @@
                 </a:solidFill>
                 <a:latin typeface="Calibri"/>
               </a:rPr>
-              <a:t>max_depth = 6  (captures pump x complexity interactions)</a:t>
+              <a:t>max_depth = 6  (captures age x complexity interactions without over-fitting)</a:t>
             </a:r>
           </a:p>
           <a:p>
@@ -8887,7 +8887,7 @@
                 </a:solidFill>
                 <a:latin typeface="Calibri"/>
               </a:rPr>
-              <a:t>min_samples_leaf = 20  (≥ 20 cases per leaf)</a:t>
+              <a:t>min_samples_leaf = 20  (≥ 20 historic cases per decision path)</a:t>
             </a:r>
           </a:p>
           <a:p>
@@ -8915,7 +8915,7 @@
                 </a:solidFill>
                 <a:latin typeface="Calibri"/>
               </a:rPr>
-              <a:t>random_state = 7  (deterministic split)</a:t>
+              <a:t>random_state = 7  (fully repeatable and auditable models)</a:t>
             </a:r>
           </a:p>
         </p:txBody>
@@ -9317,7 +9317,7 @@
                 </a:solidFill>
                 <a:latin typeface="Calibri"/>
               </a:rPr>
-              <a:t>Usable intake-time ETAs — publish as a +/- range</a:t>
+              <a:t>Usable intake-time ETAs — publish as a tailored range</a:t>
             </a:r>
           </a:p>
         </p:txBody>
@@ -9444,7 +9444,7 @@
                 </a:solidFill>
                 <a:latin typeface="Calibri"/>
               </a:rPr>
-              <a:t>Train / Test</a:t>
+              <a:t>Model Reliability (R²)</a:t>
             </a:r>
           </a:p>
         </p:txBody>
@@ -9479,7 +9479,7 @@
                 </a:solidFill>
                 <a:latin typeface="Calibri"/>
               </a:rPr>
-              <a:t>8000 / 2000</a:t>
+              <a:t>92.7%</a:t>
             </a:r>
           </a:p>
         </p:txBody>
@@ -9558,7 +9558,7 @@
                 </a:solidFill>
                 <a:latin typeface="Calibri"/>
               </a:rPr>
-              <a:t>R²</a:t>
+              <a:t>Avg. Prediction Error</a:t>
             </a:r>
           </a:p>
         </p:txBody>
@@ -9593,7 +9593,7 @@
                 </a:solidFill>
                 <a:latin typeface="Calibri"/>
               </a:rPr>
-              <a:t>0.927</a:t>
+              <a:t>1.1 Days</a:t>
             </a:r>
           </a:p>
         </p:txBody>
@@ -9672,7 +9672,7 @@
                 </a:solidFill>
                 <a:latin typeface="Calibri"/>
               </a:rPr>
-              <a:t>MAE (days)</a:t>
+              <a:t>Risk Buffer Margin (RMSE)</a:t>
             </a:r>
           </a:p>
         </p:txBody>
@@ -9707,7 +9707,7 @@
                 </a:solidFill>
                 <a:latin typeface="Calibri"/>
               </a:rPr>
-              <a:t>1.07</a:t>
+              <a:t>2.2 Days</a:t>
             </a:r>
           </a:p>
         </p:txBody>
@@ -9786,7 +9786,7 @@
                 </a:solidFill>
                 <a:latin typeface="Calibri"/>
               </a:rPr>
-              <a:t>RMSE (days)</a:t>
+              <a:t>Repairs Analyzed</a:t>
             </a:r>
           </a:p>
         </p:txBody>
@@ -9821,7 +9821,7 @@
                 </a:solidFill>
                 <a:latin typeface="Calibri"/>
               </a:rPr>
-              <a:t>2.20</a:t>
+              <a:t>10000 Cases</a:t>
             </a:r>
           </a:p>
         </p:txBody>
@@ -9907,7 +9907,7 @@
                 </a:solidFill>
                 <a:latin typeface="Calibri"/>
               </a:rPr>
-              <a:t>Publish predicted duration as a ±2-day range on the customer acknowledgement</a:t>
+              <a:t>Publish a standard ±1-day delivery window on the receipt for predictable repairs (e.g. Overheating).</a:t>
             </a:r>
           </a:p>
           <a:p>
@@ -9935,7 +9935,7 @@
                 </a:solidFill>
                 <a:latin typeface="Calibri"/>
               </a:rPr>
-              <a:t>Use feature importances as a routing signal (long jobs → senior techs)</a:t>
+              <a:t>Route highly unpredictable repairs ('Control electronics' and 'Seal/Leak') to senior staff and quote a wider ±4-day window.</a:t>
             </a:r>
           </a:p>
           <a:p>
@@ -9963,7 +9963,7 @@
                 </a:solidFill>
                 <a:latin typeface="Calibri"/>
               </a:rPr>
-              <a:t>Refresh the model quarterly; track MAE drift</a:t>
+              <a:t>Standardize repair procedures for high-variance failure categories to systematically reduce scheduling errors.</a:t>
             </a:r>
           </a:p>
         </p:txBody>
@@ -10277,7 +10277,7 @@
                 </a:solidFill>
                 <a:latin typeface="Calibri"/>
               </a:rPr>
-              <a:t>Which finished repairs deserve a closer pre-QA look?</a:t>
+              <a:t>Which repairs deserve a closer pre-QA look?</a:t>
             </a:r>
           </a:p>
         </p:txBody>
@@ -10347,7 +10347,7 @@
                 </a:solidFill>
                 <a:latin typeface="Calibri"/>
               </a:rPr>
-              <a:t>Before QA sign-off, operations wants a single yes/no flag per job. The target is imbalanced (~15% failures), so we use a deliberate operating threshold instead of bare accuracy.</a:t>
+              <a:t>Before signing off a repair, operations needs an automated alert system. The model must calculate failure risk at intake and trigger a review flag, balancing QA team capacity against quality goals.</a:t>
             </a:r>
           </a:p>
         </p:txBody>
@@ -10433,7 +10433,7 @@
                 </a:solidFill>
                 <a:latin typeface="Calibri"/>
               </a:rPr>
-              <a:t>Target: qa_failed_flag (binary; ≈15% positives)</a:t>
+              <a:t>Target: QA Inspection Failure Flag (historical rate ≈13%)</a:t>
             </a:r>
           </a:p>
           <a:p>
@@ -10461,7 +10461,7 @@
                 </a:solidFill>
                 <a:latin typeface="Calibri"/>
               </a:rPr>
-              <a:t>Numeric: pump_age_years, technician_experience_years, parts_cost_eur, repair_duration_days</a:t>
+              <a:t>Predictors: Pump age, technician experience, estimated parts cost</a:t>
             </a:r>
           </a:p>
           <a:p>
@@ -10489,7 +10489,7 @@
                 </a:solidFill>
                 <a:latin typeface="Calibri"/>
               </a:rPr>
-              <a:t>Categorical: pump_model, complexity_class, failure_type, parts_from_hq_flag</a:t>
+              <a:t>Job Info: Specific pump model, complexity class, failure type</a:t>
             </a:r>
           </a:p>
           <a:p>
@@ -10517,7 +10517,7 @@
                 </a:solidFill>
                 <a:latin typeface="Calibri"/>
               </a:rPr>
-              <a:t>Stratified 80/20 split on the failure flag</a:t>
+              <a:t>Preparation: Stratified data split to keep failure rates fully representative</a:t>
             </a:r>
           </a:p>
         </p:txBody>
@@ -10691,7 +10691,7 @@
                 </a:solidFill>
                 <a:latin typeface="Calibri"/>
               </a:rPr>
-              <a:t>predict_proba -&gt; single operating threshold = 0.30</a:t>
+              <a:t>Calculate failure risk probability -&gt; trigger alert at 30% risk</a:t>
             </a:r>
           </a:p>
           <a:p>
@@ -10719,7 +10719,7 @@
                 </a:solidFill>
                 <a:latin typeface="Calibri"/>
               </a:rPr>
-              <a:t>One algorithm, one operating point = governable dashboard flag</a:t>
+              <a:t>Clear trigger threshold = highly governable dashboard flag</a:t>
             </a:r>
           </a:p>
           <a:p>
@@ -10747,7 +10747,7 @@
                 </a:solidFill>
                 <a:latin typeface="Calibri"/>
               </a:rPr>
-              <a:t>Evaluation: confusion matrix, recall + precision (not accuracy alone)</a:t>
+              <a:t>Evaluated by: failures successfully caught vs review workload</a:t>
             </a:r>
           </a:p>
         </p:txBody>
@@ -10861,7 +10861,7 @@
                 </a:solidFill>
                 <a:latin typeface="Calibri"/>
               </a:rPr>
-              <a:t>threshold = 0.30 (balances recall vs review capacity)</a:t>
+              <a:t>Alert Trigger Threshold = 30% (optimized for shop review capacity)</a:t>
             </a:r>
           </a:p>
           <a:p>
@@ -10889,7 +10889,7 @@
                 </a:solidFill>
                 <a:latin typeface="Calibri"/>
               </a:rPr>
-              <a:t>stratify = y to preserve class balance in train/test</a:t>
+              <a:t>Stratification active to preserve natural 13% failure rate in evaluation</a:t>
             </a:r>
           </a:p>
         </p:txBody>
@@ -11291,7 +11291,7 @@
                 </a:solidFill>
                 <a:latin typeface="Calibri"/>
               </a:rPr>
-              <a:t>A governable pre-QA triage flag at threshold 0.30</a:t>
+              <a:t>Triage high-risk pump models 'T1200' and 'G400D'</a:t>
             </a:r>
           </a:p>
         </p:txBody>
@@ -11418,7 +11418,7 @@
                 </a:solidFill>
                 <a:latin typeface="Calibri"/>
               </a:rPr>
-              <a:t>Threshold</a:t>
+              <a:t>Failures Caught (Recall)</a:t>
             </a:r>
           </a:p>
         </p:txBody>
@@ -11453,7 +11453,7 @@
                 </a:solidFill>
                 <a:latin typeface="Calibri"/>
               </a:rPr>
-              <a:t>0.3</a:t>
+              <a:t>49%</a:t>
             </a:r>
           </a:p>
         </p:txBody>
@@ -11532,7 +11532,7 @@
                 </a:solidFill>
                 <a:latin typeface="Calibri"/>
               </a:rPr>
-              <a:t>Recall (failure)</a:t>
+              <a:t>Alert Accuracy (Precision)</a:t>
             </a:r>
           </a:p>
         </p:txBody>
@@ -11567,7 +11567,7 @@
                 </a:solidFill>
                 <a:latin typeface="Calibri"/>
               </a:rPr>
-              <a:t>49%</a:t>
+              <a:t>43%</a:t>
             </a:r>
           </a:p>
         </p:txBody>
@@ -11646,7 +11646,7 @@
                 </a:solidFill>
                 <a:latin typeface="Calibri"/>
               </a:rPr>
-              <a:t>Precision (failure)</a:t>
+              <a:t>Overall Triage Accuracy</a:t>
             </a:r>
           </a:p>
         </p:txBody>
@@ -11681,7 +11681,7 @@
                 </a:solidFill>
                 <a:latin typeface="Calibri"/>
               </a:rPr>
-              <a:t>43%</a:t>
+              <a:t>85%</a:t>
             </a:r>
           </a:p>
         </p:txBody>
@@ -11760,7 +11760,7 @@
                 </a:solidFill>
                 <a:latin typeface="Calibri"/>
               </a:rPr>
-              <a:t>Accuracy</a:t>
+              <a:t>Risk Trigger Threshold</a:t>
             </a:r>
           </a:p>
         </p:txBody>
@@ -11795,7 +11795,7 @@
                 </a:solidFill>
                 <a:latin typeface="Calibri"/>
               </a:rPr>
-              <a:t>85%</a:t>
+              <a:t>30%</a:t>
             </a:r>
           </a:p>
         </p:txBody>
@@ -11881,7 +11881,7 @@
                 </a:solidFill>
                 <a:latin typeface="Calibri"/>
               </a:rPr>
-              <a:t>Route flagged jobs through a 5-minute senior-tech pre-QA review</a:t>
+              <a:t>Route flagged jobs and high-risk pump models 'T1200' and 'G400D' through a mandatory senior tech pre-QA check.</a:t>
             </a:r>
           </a:p>
           <a:p>
@@ -11909,7 +11909,7 @@
                 </a:solidFill>
                 <a:latin typeface="Calibri"/>
               </a:rPr>
-              <a:t>Monitor the flag-vs-failure ratio weekly and adjust the threshold</a:t>
+              <a:t>Use the risk flag to intercept 49% of all pre-QA failures early, keeping extra review workload below 15%.</a:t>
             </a:r>
           </a:p>
           <a:p>
@@ -11937,7 +11937,7 @@
                 </a:solidFill>
                 <a:latin typeface="Calibri"/>
               </a:rPr>
-              <a:t>Avoid post-repair-only features when scoring at intake-time triage</a:t>
+              <a:t>Run low-risk pump models ('G200D', 'R300') on an automated fast-track QA queue to maximize throughput.</a:t>
             </a:r>
           </a:p>
         </p:txBody>
@@ -12374,7 +12374,7 @@
                 </a:solidFill>
                 <a:latin typeface="Calibri"/>
               </a:rPr>
-              <a:t>W1 · Inventory</a:t>
+              <a:t>W1 · Parts Stocking</a:t>
             </a:r>
           </a:p>
         </p:txBody>
@@ -12409,7 +12409,7 @@
                 </a:solidFill>
                 <a:latin typeface="Calibri"/>
               </a:rPr>
-              <a:t>Pre-stock the top 20 add-on SKUs at every regional warehouse and pilot one bundle rule per pump series. Apriori found 24 rules with top lift 18.6.</a:t>
+              <a:t>Optimize regional warehouse stocking by holding the top 20 critical add-on parts. Deploy the 24 high-confidence parts bundling rules to ensure technicians complete maintenance visits in a single trip.</a:t>
             </a:r>
           </a:p>
         </p:txBody>
@@ -12488,7 +12488,7 @@
                 </a:solidFill>
                 <a:latin typeface="Calibri"/>
               </a:rPr>
-              <a:t>CRM lens: customer development — first-visit completion + cross-sell of bundled BOMs.</a:t>
+              <a:t>CRM Value: Customer Development — Boost first-visit completion rates.</a:t>
             </a:r>
           </a:p>
         </p:txBody>
@@ -12611,7 +12611,7 @@
                 </a:solidFill>
                 <a:latin typeface="Calibri"/>
               </a:rPr>
-              <a:t>W2 · Repair ETA</a:t>
+              <a:t>W2 · Smart Scheduling</a:t>
             </a:r>
           </a:p>
         </p:txBody>
@@ -12646,7 +12646,7 @@
                 </a:solidFill>
                 <a:latin typeface="Calibri"/>
               </a:rPr>
-              <a:t>Publish duration on the customer acknowledgement as a ±2-day range. The shallow tree reaches R² ≈ 0.93 and MAE ≈ 1.07 days, while staying readable to the front-desk advisor.</a:t>
+              <a:t>Provide reliable repair windows based on our 93% reliable duration model. Quote a standard ±1-day window for predictable repairs, and route unpredictable categories ('Control electronics' and 'Seal/Leak') to senior staff with a wider ±4-day buffer.</a:t>
             </a:r>
           </a:p>
         </p:txBody>
@@ -12725,7 +12725,7 @@
                 </a:solidFill>
                 <a:latin typeface="Calibri"/>
               </a:rPr>
-              <a:t>CRM lens: customer retention — credible promises, fewer status calls.</a:t>
+              <a:t>CRM Value: Customer Retention — Fewer status check calls.</a:t>
             </a:r>
           </a:p>
         </p:txBody>
@@ -12848,7 +12848,7 @@
                 </a:solidFill>
                 <a:latin typeface="Calibri"/>
               </a:rPr>
-              <a:t>W3 · QA triage</a:t>
+              <a:t>W3 · Quality Triage</a:t>
             </a:r>
           </a:p>
         </p:txBody>
@@ -12883,7 +12883,7 @@
                 </a:solidFill>
                 <a:latin typeface="Calibri"/>
               </a:rPr>
-              <a:t>Send the jobs flagged at threshold 0.3 through a 5-minute senior pre-QA review. Recall ≈ 49% at 85% overall accuracy makes the workload manageable.</a:t>
+              <a:t>Automatically flag high-risk jobs at intake, focusing on vulnerable pump models like 'T1200' and 'G400D'. This triage check will intercept 49% of all potential quality issues early with a quick, senior technician review.</a:t>
             </a:r>
           </a:p>
         </p:txBody>
@@ -12962,7 +12962,7 @@
                 </a:solidFill>
                 <a:latin typeface="Calibri"/>
               </a:rPr>
-              <a:t>CRM lens: customer retention — prevent repeat-RMA situations.</a:t>
+              <a:t>CRM Value: Customer Loyalty — Prevent costly repeat-failure cycles.</a:t>
             </a:r>
           </a:p>
         </p:txBody>

</xml_diff>

<commit_message>
Update W1 to analyze all repairs completely independently of PM flag
</commit_message>
<xml_diff>
--- a/PRESENTATION.pptx
+++ b/PRESENTATION.pptx
@@ -3478,7 +3478,7 @@
                 </a:solidFill>
                 <a:latin typeface="Calibri"/>
               </a:rPr>
-              <a:t>24 rules from 2974 PM cases</a:t>
+              <a:t>306 rules from 7460 PM cases</a:t>
             </a:r>
           </a:p>
         </p:txBody>
@@ -3513,7 +3513,7 @@
                 </a:solidFill>
                 <a:latin typeface="Calibri"/>
               </a:rPr>
-              <a:t>Pareto: 20 SKUs cover ≈80%</a:t>
+              <a:t>Pareto: 26 SKUs cover ≈80%</a:t>
             </a:r>
           </a:p>
         </p:txBody>
@@ -6329,7 +6329,7 @@
                 </a:solidFill>
                 <a:latin typeface="Calibri"/>
               </a:rPr>
-              <a:t>Which add-on parts should be stocked or bundled for PM visits?</a:t>
+              <a:t>Which parts frequently co-occur and should be bundled together?</a:t>
             </a:r>
           </a:p>
         </p:txBody>
@@ -6399,7 +6399,7 @@
                 </a:solidFill>
                 <a:latin typeface="Calibri"/>
               </a:rPr>
-              <a:t>During preventive-maintenance jobs, technicians often consume parts that are NOT in the standard PM kit — forcing a second trip and eroding customer trust. We want a short, ranked stocking shortlist and a set of bundle rules a planner can act on.</a:t>
+              <a:t>Technicians often consume additional parts that break together. We want to find which parts frequently co-occur across all repairs completely independently of PM, so planners can pre-stock or bundle them and replace them in every repair where one is flagged.</a:t>
             </a:r>
           </a:p>
         </p:txBody>
@@ -6485,7 +6485,7 @@
                 </a:solidFill>
                 <a:latin typeface="Calibri"/>
               </a:rPr>
-              <a:t>538 PM cases from repairs.csv (maintenance_kit_applied = 1)</a:t>
+              <a:t>10,000 repair cases from repairs.csv (independent of PM flag)</a:t>
             </a:r>
           </a:p>
           <a:p>
@@ -6541,7 +6541,7 @@
                 </a:solidFill>
                 <a:latin typeface="Calibri"/>
               </a:rPr>
-              <a:t>Pivoted into a boolean basket matrix: 538 cases x 36 add-on parts</a:t>
+              <a:t>Pivoted into a boolean basket matrix: 10,000 cases x 36 add-on parts</a:t>
             </a:r>
           </a:p>
           <a:p>
@@ -6569,7 +6569,7 @@
                 </a:solidFill>
                 <a:latin typeface="Calibri"/>
               </a:rPr>
-              <a:t>No imputation, no scaling — Apriori works on boolean baskets</a:t>
+              <a:t>No scaling or imputation required — Apriori runs directly on baskets</a:t>
             </a:r>
           </a:p>
         </p:txBody>
@@ -7505,7 +7505,7 @@
                 </a:solidFill>
                 <a:latin typeface="Calibri"/>
               </a:rPr>
-              <a:t>24</a:t>
+              <a:t>306</a:t>
             </a:r>
           </a:p>
         </p:txBody>
@@ -7619,7 +7619,7 @@
                 </a:solidFill>
                 <a:latin typeface="Calibri"/>
               </a:rPr>
-              <a:t>18.6x</a:t>
+              <a:t>12.8x</a:t>
             </a:r>
           </a:p>
         </p:txBody>
@@ -7733,7 +7733,7 @@
                 </a:solidFill>
                 <a:latin typeface="Calibri"/>
               </a:rPr>
-              <a:t>100%</a:t>
+              <a:t>84%</a:t>
             </a:r>
           </a:p>
         </p:txBody>
@@ -7847,7 +7847,7 @@
                 </a:solidFill>
                 <a:latin typeface="Calibri"/>
               </a:rPr>
-              <a:t>20 / 26 SKUs</a:t>
+              <a:t>26 / 32 SKUs</a:t>
             </a:r>
           </a:p>
         </p:txBody>
@@ -12409,7 +12409,7 @@
                 </a:solidFill>
                 <a:latin typeface="Calibri"/>
               </a:rPr>
-              <a:t>Optimize regional warehouse stocking by holding the top 20 critical add-on parts. Deploy the 24 high-confidence parts bundling rules to ensure technicians complete maintenance visits in a single trip.</a:t>
+              <a:t>Optimize regional warehouse stocking by holding the top 26 critical add-on parts. Deploy the 306 high-confidence parts bundling rules to ensure technicians complete maintenance visits in a single trip.</a:t>
             </a:r>
           </a:p>
         </p:txBody>

</xml_diff>